<commit_message>
Added Lecture 34 and EOS solver for fugacity
</commit_message>
<xml_diff>
--- a/class33/images/images.pptx
+++ b/class33/images/images.pptx
@@ -5734,10 +5734,10 @@
       </p:grpSpPr>
       <p:grpSp>
         <p:nvGrpSpPr>
-          <p:cNvPr id="6" name="Group 5">
+          <p:cNvPr id="10" name="Group 9">
             <a:extLst>
               <a:ext uri="{FF2B5EF4-FFF2-40B4-BE49-F238E27FC236}">
-                <a16:creationId xmlns:a16="http://schemas.microsoft.com/office/drawing/2014/main" id="{7BBCE5CD-5031-506A-DEEA-114A82D14090}"/>
+                <a16:creationId xmlns:a16="http://schemas.microsoft.com/office/drawing/2014/main" id="{B4A88784-E05A-1E15-48CE-68D87F1F5BCC}"/>
               </a:ext>
             </a:extLst>
           </p:cNvPr>
@@ -5754,10 +5754,10 @@
         </p:grpSpPr>
         <p:grpSp>
           <p:nvGrpSpPr>
-            <p:cNvPr id="28" name="Group 27">
+            <p:cNvPr id="6" name="Group 5">
               <a:extLst>
                 <a:ext uri="{FF2B5EF4-FFF2-40B4-BE49-F238E27FC236}">
-                  <a16:creationId xmlns:a16="http://schemas.microsoft.com/office/drawing/2014/main" id="{0CAD43CF-C606-8A26-04D2-1F745680020D}"/>
+                  <a16:creationId xmlns:a16="http://schemas.microsoft.com/office/drawing/2014/main" id="{7BBCE5CD-5031-506A-DEEA-114A82D14090}"/>
                 </a:ext>
               </a:extLst>
             </p:cNvPr>
@@ -5766,202 +5766,468 @@
           </p:nvGrpSpPr>
           <p:grpSpPr>
             <a:xfrm>
-              <a:off x="1853852" y="1164921"/>
-              <a:ext cx="6463430" cy="4352608"/>
-              <a:chOff x="1853852" y="1164921"/>
-              <a:chExt cx="6463430" cy="4352608"/>
+              <a:off x="1853852" y="989556"/>
+              <a:ext cx="6463430" cy="4527973"/>
+              <a:chOff x="1853852" y="989556"/>
+              <a:chExt cx="6463430" cy="4527973"/>
             </a:xfrm>
           </p:grpSpPr>
-          <p:cxnSp>
-            <p:nvCxnSpPr>
-              <p:cNvPr id="3" name="Straight Connector 2">
+          <p:grpSp>
+            <p:nvGrpSpPr>
+              <p:cNvPr id="28" name="Group 27">
                 <a:extLst>
                   <a:ext uri="{FF2B5EF4-FFF2-40B4-BE49-F238E27FC236}">
-                    <a16:creationId xmlns:a16="http://schemas.microsoft.com/office/drawing/2014/main" id="{ED9B8B4F-2414-D1DA-D84F-768A28AB59C4}"/>
+                    <a16:creationId xmlns:a16="http://schemas.microsoft.com/office/drawing/2014/main" id="{0CAD43CF-C606-8A26-04D2-1F745680020D}"/>
                   </a:ext>
                 </a:extLst>
               </p:cNvPr>
-              <p:cNvCxnSpPr/>
+              <p:cNvGrpSpPr/>
               <p:nvPr/>
-            </p:nvCxnSpPr>
-            <p:spPr>
+            </p:nvGrpSpPr>
+            <p:grpSpPr>
               <a:xfrm>
-                <a:off x="2192055" y="1164921"/>
-                <a:ext cx="0" cy="3858016"/>
+                <a:off x="1853852" y="1164921"/>
+                <a:ext cx="6463430" cy="4352608"/>
+                <a:chOff x="1853852" y="1164921"/>
+                <a:chExt cx="6463430" cy="4352608"/>
               </a:xfrm>
-              <a:prstGeom prst="line">
-                <a:avLst/>
-              </a:prstGeom>
-            </p:spPr>
-            <p:style>
-              <a:lnRef idx="2">
-                <a:schemeClr val="accent1"/>
-              </a:lnRef>
-              <a:fillRef idx="0">
-                <a:schemeClr val="accent1"/>
-              </a:fillRef>
-              <a:effectRef idx="1">
-                <a:schemeClr val="accent1"/>
-              </a:effectRef>
-              <a:fontRef idx="minor">
-                <a:schemeClr val="tx1"/>
-              </a:fontRef>
-            </p:style>
-          </p:cxnSp>
-          <p:cxnSp>
-            <p:nvCxnSpPr>
-              <p:cNvPr id="4" name="Straight Connector 3">
+            </p:grpSpPr>
+            <p:cxnSp>
+              <p:nvCxnSpPr>
+                <p:cNvPr id="3" name="Straight Connector 2">
+                  <a:extLst>
+                    <a:ext uri="{FF2B5EF4-FFF2-40B4-BE49-F238E27FC236}">
+                      <a16:creationId xmlns:a16="http://schemas.microsoft.com/office/drawing/2014/main" id="{ED9B8B4F-2414-D1DA-D84F-768A28AB59C4}"/>
+                    </a:ext>
+                  </a:extLst>
+                </p:cNvPr>
+                <p:cNvCxnSpPr/>
+                <p:nvPr/>
+              </p:nvCxnSpPr>
+              <p:spPr>
+                <a:xfrm>
+                  <a:off x="2192055" y="1164921"/>
+                  <a:ext cx="0" cy="3858016"/>
+                </a:xfrm>
+                <a:prstGeom prst="line">
+                  <a:avLst/>
+                </a:prstGeom>
+              </p:spPr>
+              <p:style>
+                <a:lnRef idx="2">
+                  <a:schemeClr val="accent1"/>
+                </a:lnRef>
+                <a:fillRef idx="0">
+                  <a:schemeClr val="accent1"/>
+                </a:fillRef>
+                <a:effectRef idx="1">
+                  <a:schemeClr val="accent1"/>
+                </a:effectRef>
+                <a:fontRef idx="minor">
+                  <a:schemeClr val="tx1"/>
+                </a:fontRef>
+              </p:style>
+            </p:cxnSp>
+            <p:cxnSp>
+              <p:nvCxnSpPr>
+                <p:cNvPr id="4" name="Straight Connector 3">
+                  <a:extLst>
+                    <a:ext uri="{FF2B5EF4-FFF2-40B4-BE49-F238E27FC236}">
+                      <a16:creationId xmlns:a16="http://schemas.microsoft.com/office/drawing/2014/main" id="{FD523AA7-0093-DE9C-2B35-D65837C6A45B}"/>
+                    </a:ext>
+                  </a:extLst>
+                </p:cNvPr>
+                <p:cNvCxnSpPr>
+                  <a:cxnSpLocks/>
+                </p:cNvCxnSpPr>
+                <p:nvPr/>
+              </p:nvCxnSpPr>
+              <p:spPr>
+                <a:xfrm flipH="1">
+                  <a:off x="2192055" y="5022937"/>
+                  <a:ext cx="6125227" cy="2088"/>
+                </a:xfrm>
+                <a:prstGeom prst="line">
+                  <a:avLst/>
+                </a:prstGeom>
+              </p:spPr>
+              <p:style>
+                <a:lnRef idx="2">
+                  <a:schemeClr val="accent1"/>
+                </a:lnRef>
+                <a:fillRef idx="0">
+                  <a:schemeClr val="accent1"/>
+                </a:fillRef>
+                <a:effectRef idx="1">
+                  <a:schemeClr val="accent1"/>
+                </a:effectRef>
+                <a:fontRef idx="minor">
+                  <a:schemeClr val="tx1"/>
+                </a:fontRef>
+              </p:style>
+            </p:cxnSp>
+            <p:cxnSp>
+              <p:nvCxnSpPr>
+                <p:cNvPr id="7" name="Straight Connector 6">
+                  <a:extLst>
+                    <a:ext uri="{FF2B5EF4-FFF2-40B4-BE49-F238E27FC236}">
+                      <a16:creationId xmlns:a16="http://schemas.microsoft.com/office/drawing/2014/main" id="{7CA3706E-BCD4-6057-EAB8-A1887F117442}"/>
+                    </a:ext>
+                  </a:extLst>
+                </p:cNvPr>
+                <p:cNvCxnSpPr/>
+                <p:nvPr/>
+              </p:nvCxnSpPr>
+              <p:spPr>
+                <a:xfrm flipV="1">
+                  <a:off x="3469710" y="3429000"/>
+                  <a:ext cx="1177446" cy="804797"/>
+                </a:xfrm>
+                <a:prstGeom prst="line">
+                  <a:avLst/>
+                </a:prstGeom>
+              </p:spPr>
+              <p:style>
+                <a:lnRef idx="2">
+                  <a:schemeClr val="accent1"/>
+                </a:lnRef>
+                <a:fillRef idx="0">
+                  <a:schemeClr val="accent1"/>
+                </a:fillRef>
+                <a:effectRef idx="1">
+                  <a:schemeClr val="accent1"/>
+                </a:effectRef>
+                <a:fontRef idx="minor">
+                  <a:schemeClr val="tx1"/>
+                </a:fontRef>
+              </p:style>
+            </p:cxnSp>
+            <p:cxnSp>
+              <p:nvCxnSpPr>
+                <p:cNvPr id="9" name="Straight Connector 8">
+                  <a:extLst>
+                    <a:ext uri="{FF2B5EF4-FFF2-40B4-BE49-F238E27FC236}">
+                      <a16:creationId xmlns:a16="http://schemas.microsoft.com/office/drawing/2014/main" id="{C1E5B3E0-DFE9-B4F7-0D40-8AD38646B433}"/>
+                    </a:ext>
+                  </a:extLst>
+                </p:cNvPr>
+                <p:cNvCxnSpPr>
+                  <a:cxnSpLocks/>
+                </p:cNvCxnSpPr>
+                <p:nvPr/>
+              </p:nvCxnSpPr>
+              <p:spPr>
+                <a:xfrm flipH="1" flipV="1">
+                  <a:off x="4619284" y="1847403"/>
+                  <a:ext cx="40398" cy="1581597"/>
+                </a:xfrm>
+                <a:prstGeom prst="line">
+                  <a:avLst/>
+                </a:prstGeom>
+              </p:spPr>
+              <p:style>
+                <a:lnRef idx="2">
+                  <a:schemeClr val="accent1"/>
+                </a:lnRef>
+                <a:fillRef idx="0">
+                  <a:schemeClr val="accent1"/>
+                </a:fillRef>
+                <a:effectRef idx="1">
+                  <a:schemeClr val="accent1"/>
+                </a:effectRef>
+                <a:fontRef idx="minor">
+                  <a:schemeClr val="tx1"/>
+                </a:fontRef>
+              </p:style>
+            </p:cxnSp>
+            <p:cxnSp>
+              <p:nvCxnSpPr>
+                <p:cNvPr id="11" name="Straight Connector 10">
+                  <a:extLst>
+                    <a:ext uri="{FF2B5EF4-FFF2-40B4-BE49-F238E27FC236}">
+                      <a16:creationId xmlns:a16="http://schemas.microsoft.com/office/drawing/2014/main" id="{B665FC76-4EEF-0DA8-DF3B-EDF60C38EB94}"/>
+                    </a:ext>
+                  </a:extLst>
+                </p:cNvPr>
+                <p:cNvCxnSpPr/>
+                <p:nvPr/>
+              </p:nvCxnSpPr>
+              <p:spPr>
+                <a:xfrm flipV="1">
+                  <a:off x="4647156" y="2705622"/>
+                  <a:ext cx="2455102" cy="723378"/>
+                </a:xfrm>
+                <a:prstGeom prst="line">
+                  <a:avLst/>
+                </a:prstGeom>
+              </p:spPr>
+              <p:style>
+                <a:lnRef idx="2">
+                  <a:schemeClr val="accent1"/>
+                </a:lnRef>
+                <a:fillRef idx="0">
+                  <a:schemeClr val="accent1"/>
+                </a:fillRef>
+                <a:effectRef idx="1">
+                  <a:schemeClr val="accent1"/>
+                </a:effectRef>
+                <a:fontRef idx="minor">
+                  <a:schemeClr val="tx1"/>
+                </a:fontRef>
+              </p:style>
+            </p:cxnSp>
+            <p:sp>
+              <p:nvSpPr>
+                <p:cNvPr id="12" name="TextBox 11">
+                  <a:extLst>
+                    <a:ext uri="{FF2B5EF4-FFF2-40B4-BE49-F238E27FC236}">
+                      <a16:creationId xmlns:a16="http://schemas.microsoft.com/office/drawing/2014/main" id="{C5B7A361-319E-184E-3E8E-3CCDCBA91D1A}"/>
+                    </a:ext>
+                  </a:extLst>
+                </p:cNvPr>
+                <p:cNvSpPr txBox="1"/>
+                <p:nvPr/>
+              </p:nvSpPr>
+              <p:spPr>
+                <a:xfrm>
+                  <a:off x="3933172" y="2289039"/>
+                  <a:ext cx="521493" cy="369332"/>
+                </a:xfrm>
+                <a:prstGeom prst="rect">
+                  <a:avLst/>
+                </a:prstGeom>
+                <a:noFill/>
+              </p:spPr>
+              <p:txBody>
+                <a:bodyPr wrap="square" rtlCol="0">
+                  <a:spAutoFit/>
+                </a:bodyPr>
+                <a:lstStyle/>
+                <a:p>
+                  <a:r>
+                    <a:rPr lang="en-US" dirty="0"/>
+                    <a:t>S</a:t>
+                  </a:r>
+                </a:p>
+              </p:txBody>
+            </p:sp>
+            <p:sp>
+              <p:nvSpPr>
+                <p:cNvPr id="13" name="TextBox 12">
+                  <a:extLst>
+                    <a:ext uri="{FF2B5EF4-FFF2-40B4-BE49-F238E27FC236}">
+                      <a16:creationId xmlns:a16="http://schemas.microsoft.com/office/drawing/2014/main" id="{970F4C89-DA10-17FF-3FC8-009E0C91BE7A}"/>
+                    </a:ext>
+                  </a:extLst>
+                </p:cNvPr>
+                <p:cNvSpPr txBox="1"/>
+                <p:nvPr/>
+              </p:nvSpPr>
+              <p:spPr>
+                <a:xfrm>
+                  <a:off x="5546210" y="2340569"/>
+                  <a:ext cx="526092" cy="369332"/>
+                </a:xfrm>
+                <a:prstGeom prst="rect">
+                  <a:avLst/>
+                </a:prstGeom>
+                <a:noFill/>
+              </p:spPr>
+              <p:txBody>
+                <a:bodyPr wrap="square" rtlCol="0">
+                  <a:spAutoFit/>
+                </a:bodyPr>
+                <a:lstStyle/>
+                <a:p>
+                  <a:r>
+                    <a:rPr lang="en-US" dirty="0"/>
+                    <a:t>L</a:t>
+                  </a:r>
+                </a:p>
+              </p:txBody>
+            </p:sp>
+            <p:sp>
+              <p:nvSpPr>
+                <p:cNvPr id="14" name="TextBox 13">
+                  <a:extLst>
+                    <a:ext uri="{FF2B5EF4-FFF2-40B4-BE49-F238E27FC236}">
+                      <a16:creationId xmlns:a16="http://schemas.microsoft.com/office/drawing/2014/main" id="{9DFAE45E-A65A-E619-D63C-046E1D916E09}"/>
+                    </a:ext>
+                  </a:extLst>
+                </p:cNvPr>
+                <p:cNvSpPr txBox="1"/>
+                <p:nvPr/>
+              </p:nvSpPr>
+              <p:spPr>
+                <a:xfrm>
+                  <a:off x="6400800" y="3645074"/>
+                  <a:ext cx="319318" cy="369332"/>
+                </a:xfrm>
+                <a:prstGeom prst="rect">
+                  <a:avLst/>
+                </a:prstGeom>
+                <a:noFill/>
+              </p:spPr>
+              <p:txBody>
+                <a:bodyPr wrap="none" rtlCol="0">
+                  <a:spAutoFit/>
+                </a:bodyPr>
+                <a:lstStyle/>
+                <a:p>
+                  <a:r>
+                    <a:rPr lang="en-US" dirty="0"/>
+                    <a:t>V</a:t>
+                  </a:r>
+                </a:p>
+              </p:txBody>
+            </p:sp>
+            <p:sp>
+              <p:nvSpPr>
+                <p:cNvPr id="15" name="TextBox 14">
+                  <a:extLst>
+                    <a:ext uri="{FF2B5EF4-FFF2-40B4-BE49-F238E27FC236}">
+                      <a16:creationId xmlns:a16="http://schemas.microsoft.com/office/drawing/2014/main" id="{FCBCC5B2-1E54-546D-73C0-5C1FF7B987DC}"/>
+                    </a:ext>
+                  </a:extLst>
+                </p:cNvPr>
+                <p:cNvSpPr txBox="1"/>
+                <p:nvPr/>
+              </p:nvSpPr>
+              <p:spPr>
+                <a:xfrm>
+                  <a:off x="4621060" y="3413157"/>
+                  <a:ext cx="521497" cy="369332"/>
+                </a:xfrm>
+                <a:prstGeom prst="rect">
+                  <a:avLst/>
+                </a:prstGeom>
+                <a:noFill/>
+              </p:spPr>
+              <p:txBody>
+                <a:bodyPr wrap="square" rtlCol="0">
+                  <a:spAutoFit/>
+                </a:bodyPr>
+                <a:lstStyle/>
+                <a:p>
+                  <a:r>
+                    <a:rPr lang="en-US" dirty="0"/>
+                    <a:t>TP</a:t>
+                  </a:r>
+                </a:p>
+              </p:txBody>
+            </p:sp>
+            <p:sp>
+              <p:nvSpPr>
+                <p:cNvPr id="16" name="TextBox 15">
+                  <a:extLst>
+                    <a:ext uri="{FF2B5EF4-FFF2-40B4-BE49-F238E27FC236}">
+                      <a16:creationId xmlns:a16="http://schemas.microsoft.com/office/drawing/2014/main" id="{D76D2EF3-30F5-DE8E-3259-C52EC3A56A40}"/>
+                    </a:ext>
+                  </a:extLst>
+                </p:cNvPr>
+                <p:cNvSpPr txBox="1"/>
+                <p:nvPr/>
+              </p:nvSpPr>
+              <p:spPr>
+                <a:xfrm>
+                  <a:off x="7078563" y="2473705"/>
+                  <a:ext cx="526093" cy="369332"/>
+                </a:xfrm>
+                <a:prstGeom prst="rect">
+                  <a:avLst/>
+                </a:prstGeom>
+                <a:noFill/>
+              </p:spPr>
+              <p:txBody>
+                <a:bodyPr wrap="square" rtlCol="0">
+                  <a:spAutoFit/>
+                </a:bodyPr>
+                <a:lstStyle/>
+                <a:p>
+                  <a:r>
+                    <a:rPr lang="en-US" dirty="0"/>
+                    <a:t>C</a:t>
+                  </a:r>
+                </a:p>
+              </p:txBody>
+            </p:sp>
+            <p:sp>
+              <p:nvSpPr>
+                <p:cNvPr id="26" name="TextBox 25">
+                  <a:extLst>
+                    <a:ext uri="{FF2B5EF4-FFF2-40B4-BE49-F238E27FC236}">
+                      <a16:creationId xmlns:a16="http://schemas.microsoft.com/office/drawing/2014/main" id="{8C416952-CAB2-C7C5-6840-C2BB2171ECD0}"/>
+                    </a:ext>
+                  </a:extLst>
+                </p:cNvPr>
+                <p:cNvSpPr txBox="1"/>
+                <p:nvPr/>
+              </p:nvSpPr>
+              <p:spPr>
+                <a:xfrm>
+                  <a:off x="1853852" y="1478071"/>
+                  <a:ext cx="317716" cy="369332"/>
+                </a:xfrm>
+                <a:prstGeom prst="rect">
+                  <a:avLst/>
+                </a:prstGeom>
+                <a:noFill/>
+              </p:spPr>
+              <p:txBody>
+                <a:bodyPr wrap="none" rtlCol="0">
+                  <a:spAutoFit/>
+                </a:bodyPr>
+                <a:lstStyle/>
+                <a:p>
+                  <a:r>
+                    <a:rPr lang="en-US" dirty="0"/>
+                    <a:t>P</a:t>
+                  </a:r>
+                </a:p>
+              </p:txBody>
+            </p:sp>
+            <p:sp>
+              <p:nvSpPr>
+                <p:cNvPr id="27" name="TextBox 26">
+                  <a:extLst>
+                    <a:ext uri="{FF2B5EF4-FFF2-40B4-BE49-F238E27FC236}">
+                      <a16:creationId xmlns:a16="http://schemas.microsoft.com/office/drawing/2014/main" id="{32BCD7D9-A860-7D4B-61C6-5925834071A3}"/>
+                    </a:ext>
+                  </a:extLst>
+                </p:cNvPr>
+                <p:cNvSpPr txBox="1"/>
+                <p:nvPr/>
+              </p:nvSpPr>
+              <p:spPr>
+                <a:xfrm>
+                  <a:off x="7341609" y="5148197"/>
+                  <a:ext cx="295274" cy="369332"/>
+                </a:xfrm>
+                <a:prstGeom prst="rect">
+                  <a:avLst/>
+                </a:prstGeom>
+                <a:noFill/>
+              </p:spPr>
+              <p:txBody>
+                <a:bodyPr wrap="none" rtlCol="0">
+                  <a:spAutoFit/>
+                </a:bodyPr>
+                <a:lstStyle/>
+                <a:p>
+                  <a:r>
+                    <a:rPr lang="en-US" dirty="0"/>
+                    <a:t>T</a:t>
+                  </a:r>
+                </a:p>
+              </p:txBody>
+            </p:sp>
+          </p:grpSp>
+          <p:sp>
+            <p:nvSpPr>
+              <p:cNvPr id="2" name="TextBox 1">
                 <a:extLst>
                   <a:ext uri="{FF2B5EF4-FFF2-40B4-BE49-F238E27FC236}">
-                    <a16:creationId xmlns:a16="http://schemas.microsoft.com/office/drawing/2014/main" id="{FD523AA7-0093-DE9C-2B35-D65837C6A45B}"/>
-                  </a:ext>
-                </a:extLst>
-              </p:cNvPr>
-              <p:cNvCxnSpPr>
-                <a:cxnSpLocks/>
-              </p:cNvCxnSpPr>
-              <p:nvPr/>
-            </p:nvCxnSpPr>
-            <p:spPr>
-              <a:xfrm flipH="1">
-                <a:off x="2192055" y="5022937"/>
-                <a:ext cx="6125227" cy="2088"/>
-              </a:xfrm>
-              <a:prstGeom prst="line">
-                <a:avLst/>
-              </a:prstGeom>
-            </p:spPr>
-            <p:style>
-              <a:lnRef idx="2">
-                <a:schemeClr val="accent1"/>
-              </a:lnRef>
-              <a:fillRef idx="0">
-                <a:schemeClr val="accent1"/>
-              </a:fillRef>
-              <a:effectRef idx="1">
-                <a:schemeClr val="accent1"/>
-              </a:effectRef>
-              <a:fontRef idx="minor">
-                <a:schemeClr val="tx1"/>
-              </a:fontRef>
-            </p:style>
-          </p:cxnSp>
-          <p:cxnSp>
-            <p:nvCxnSpPr>
-              <p:cNvPr id="7" name="Straight Connector 6">
-                <a:extLst>
-                  <a:ext uri="{FF2B5EF4-FFF2-40B4-BE49-F238E27FC236}">
-                    <a16:creationId xmlns:a16="http://schemas.microsoft.com/office/drawing/2014/main" id="{7CA3706E-BCD4-6057-EAB8-A1887F117442}"/>
-                  </a:ext>
-                </a:extLst>
-              </p:cNvPr>
-              <p:cNvCxnSpPr/>
-              <p:nvPr/>
-            </p:nvCxnSpPr>
-            <p:spPr>
-              <a:xfrm flipV="1">
-                <a:off x="3469710" y="3429000"/>
-                <a:ext cx="1177446" cy="804797"/>
-              </a:xfrm>
-              <a:prstGeom prst="line">
-                <a:avLst/>
-              </a:prstGeom>
-            </p:spPr>
-            <p:style>
-              <a:lnRef idx="2">
-                <a:schemeClr val="accent1"/>
-              </a:lnRef>
-              <a:fillRef idx="0">
-                <a:schemeClr val="accent1"/>
-              </a:fillRef>
-              <a:effectRef idx="1">
-                <a:schemeClr val="accent1"/>
-              </a:effectRef>
-              <a:fontRef idx="minor">
-                <a:schemeClr val="tx1"/>
-              </a:fontRef>
-            </p:style>
-          </p:cxnSp>
-          <p:cxnSp>
-            <p:nvCxnSpPr>
-              <p:cNvPr id="9" name="Straight Connector 8">
-                <a:extLst>
-                  <a:ext uri="{FF2B5EF4-FFF2-40B4-BE49-F238E27FC236}">
-                    <a16:creationId xmlns:a16="http://schemas.microsoft.com/office/drawing/2014/main" id="{C1E5B3E0-DFE9-B4F7-0D40-8AD38646B433}"/>
-                  </a:ext>
-                </a:extLst>
-              </p:cNvPr>
-              <p:cNvCxnSpPr>
-                <a:cxnSpLocks/>
-              </p:cNvCxnSpPr>
-              <p:nvPr/>
-            </p:nvCxnSpPr>
-            <p:spPr>
-              <a:xfrm flipH="1" flipV="1">
-                <a:off x="4619284" y="1847403"/>
-                <a:ext cx="40398" cy="1581597"/>
-              </a:xfrm>
-              <a:prstGeom prst="line">
-                <a:avLst/>
-              </a:prstGeom>
-            </p:spPr>
-            <p:style>
-              <a:lnRef idx="2">
-                <a:schemeClr val="accent1"/>
-              </a:lnRef>
-              <a:fillRef idx="0">
-                <a:schemeClr val="accent1"/>
-              </a:fillRef>
-              <a:effectRef idx="1">
-                <a:schemeClr val="accent1"/>
-              </a:effectRef>
-              <a:fontRef idx="minor">
-                <a:schemeClr val="tx1"/>
-              </a:fontRef>
-            </p:style>
-          </p:cxnSp>
-          <p:cxnSp>
-            <p:nvCxnSpPr>
-              <p:cNvPr id="11" name="Straight Connector 10">
-                <a:extLst>
-                  <a:ext uri="{FF2B5EF4-FFF2-40B4-BE49-F238E27FC236}">
-                    <a16:creationId xmlns:a16="http://schemas.microsoft.com/office/drawing/2014/main" id="{B665FC76-4EEF-0DA8-DF3B-EDF60C38EB94}"/>
-                  </a:ext>
-                </a:extLst>
-              </p:cNvPr>
-              <p:cNvCxnSpPr/>
-              <p:nvPr/>
-            </p:nvCxnSpPr>
-            <p:spPr>
-              <a:xfrm flipV="1">
-                <a:off x="4647156" y="2705622"/>
-                <a:ext cx="2455102" cy="723378"/>
-              </a:xfrm>
-              <a:prstGeom prst="line">
-                <a:avLst/>
-              </a:prstGeom>
-            </p:spPr>
-            <p:style>
-              <a:lnRef idx="2">
-                <a:schemeClr val="accent1"/>
-              </a:lnRef>
-              <a:fillRef idx="0">
-                <a:schemeClr val="accent1"/>
-              </a:fillRef>
-              <a:effectRef idx="1">
-                <a:schemeClr val="accent1"/>
-              </a:effectRef>
-              <a:fontRef idx="minor">
-                <a:schemeClr val="tx1"/>
-              </a:fontRef>
-            </p:style>
-          </p:cxnSp>
-          <p:sp>
-            <p:nvSpPr>
-              <p:cNvPr id="12" name="TextBox 11">
-                <a:extLst>
-                  <a:ext uri="{FF2B5EF4-FFF2-40B4-BE49-F238E27FC236}">
-                    <a16:creationId xmlns:a16="http://schemas.microsoft.com/office/drawing/2014/main" id="{C5B7A361-319E-184E-3E8E-3CCDCBA91D1A}"/>
+                    <a16:creationId xmlns:a16="http://schemas.microsoft.com/office/drawing/2014/main" id="{198BCECC-52FA-5A31-417F-2498057E2510}"/>
                   </a:ext>
                 </a:extLst>
               </p:cNvPr>
@@ -5970,78 +6236,8 @@
             </p:nvSpPr>
             <p:spPr>
               <a:xfrm>
-                <a:off x="3933172" y="2289039"/>
-                <a:ext cx="521493" cy="369332"/>
-              </a:xfrm>
-              <a:prstGeom prst="rect">
-                <a:avLst/>
-              </a:prstGeom>
-              <a:noFill/>
-            </p:spPr>
-            <p:txBody>
-              <a:bodyPr wrap="square" rtlCol="0">
-                <a:spAutoFit/>
-              </a:bodyPr>
-              <a:lstStyle/>
-              <a:p>
-                <a:r>
-                  <a:rPr lang="en-US" dirty="0"/>
-                  <a:t>S</a:t>
-                </a:r>
-              </a:p>
-            </p:txBody>
-          </p:sp>
-          <p:sp>
-            <p:nvSpPr>
-              <p:cNvPr id="13" name="TextBox 12">
-                <a:extLst>
-                  <a:ext uri="{FF2B5EF4-FFF2-40B4-BE49-F238E27FC236}">
-                    <a16:creationId xmlns:a16="http://schemas.microsoft.com/office/drawing/2014/main" id="{970F4C89-DA10-17FF-3FC8-009E0C91BE7A}"/>
-                  </a:ext>
-                </a:extLst>
-              </p:cNvPr>
-              <p:cNvSpPr txBox="1"/>
-              <p:nvPr/>
-            </p:nvSpPr>
-            <p:spPr>
-              <a:xfrm>
-                <a:off x="5546210" y="2340569"/>
-                <a:ext cx="526092" cy="369332"/>
-              </a:xfrm>
-              <a:prstGeom prst="rect">
-                <a:avLst/>
-              </a:prstGeom>
-              <a:noFill/>
-            </p:spPr>
-            <p:txBody>
-              <a:bodyPr wrap="square" rtlCol="0">
-                <a:spAutoFit/>
-              </a:bodyPr>
-              <a:lstStyle/>
-              <a:p>
-                <a:r>
-                  <a:rPr lang="en-US" dirty="0"/>
-                  <a:t>L</a:t>
-                </a:r>
-              </a:p>
-            </p:txBody>
-          </p:sp>
-          <p:sp>
-            <p:nvSpPr>
-              <p:cNvPr id="14" name="TextBox 13">
-                <a:extLst>
-                  <a:ext uri="{FF2B5EF4-FFF2-40B4-BE49-F238E27FC236}">
-                    <a16:creationId xmlns:a16="http://schemas.microsoft.com/office/drawing/2014/main" id="{9DFAE45E-A65A-E619-D63C-046E1D916E09}"/>
-                  </a:ext>
-                </a:extLst>
-              </p:cNvPr>
-              <p:cNvSpPr txBox="1"/>
-              <p:nvPr/>
-            </p:nvSpPr>
-            <p:spPr>
-              <a:xfrm>
-                <a:off x="6400800" y="3645074"/>
-                <a:ext cx="319318" cy="369332"/>
+                <a:off x="5142557" y="989556"/>
+                <a:ext cx="777457" cy="369332"/>
               </a:xfrm>
               <a:prstGeom prst="rect">
                 <a:avLst/>
@@ -6055,148 +6251,8 @@
               <a:lstStyle/>
               <a:p>
                 <a:r>
-                  <a:rPr lang="en-US" dirty="0"/>
-                  <a:t>V</a:t>
-                </a:r>
-              </a:p>
-            </p:txBody>
-          </p:sp>
-          <p:sp>
-            <p:nvSpPr>
-              <p:cNvPr id="15" name="TextBox 14">
-                <a:extLst>
-                  <a:ext uri="{FF2B5EF4-FFF2-40B4-BE49-F238E27FC236}">
-                    <a16:creationId xmlns:a16="http://schemas.microsoft.com/office/drawing/2014/main" id="{FCBCC5B2-1E54-546D-73C0-5C1FF7B987DC}"/>
-                  </a:ext>
-                </a:extLst>
-              </p:cNvPr>
-              <p:cNvSpPr txBox="1"/>
-              <p:nvPr/>
-            </p:nvSpPr>
-            <p:spPr>
-              <a:xfrm>
-                <a:off x="4621060" y="3413157"/>
-                <a:ext cx="521497" cy="369332"/>
-              </a:xfrm>
-              <a:prstGeom prst="rect">
-                <a:avLst/>
-              </a:prstGeom>
-              <a:noFill/>
-            </p:spPr>
-            <p:txBody>
-              <a:bodyPr wrap="square" rtlCol="0">
-                <a:spAutoFit/>
-              </a:bodyPr>
-              <a:lstStyle/>
-              <a:p>
-                <a:r>
-                  <a:rPr lang="en-US" dirty="0"/>
-                  <a:t>TP</a:t>
-                </a:r>
-              </a:p>
-            </p:txBody>
-          </p:sp>
-          <p:sp>
-            <p:nvSpPr>
-              <p:cNvPr id="16" name="TextBox 15">
-                <a:extLst>
-                  <a:ext uri="{FF2B5EF4-FFF2-40B4-BE49-F238E27FC236}">
-                    <a16:creationId xmlns:a16="http://schemas.microsoft.com/office/drawing/2014/main" id="{D76D2EF3-30F5-DE8E-3259-C52EC3A56A40}"/>
-                  </a:ext>
-                </a:extLst>
-              </p:cNvPr>
-              <p:cNvSpPr txBox="1"/>
-              <p:nvPr/>
-            </p:nvSpPr>
-            <p:spPr>
-              <a:xfrm>
-                <a:off x="7078563" y="2473705"/>
-                <a:ext cx="526093" cy="369332"/>
-              </a:xfrm>
-              <a:prstGeom prst="rect">
-                <a:avLst/>
-              </a:prstGeom>
-              <a:noFill/>
-            </p:spPr>
-            <p:txBody>
-              <a:bodyPr wrap="square" rtlCol="0">
-                <a:spAutoFit/>
-              </a:bodyPr>
-              <a:lstStyle/>
-              <a:p>
-                <a:r>
-                  <a:rPr lang="en-US" dirty="0"/>
-                  <a:t>C</a:t>
-                </a:r>
-              </a:p>
-            </p:txBody>
-          </p:sp>
-          <p:sp>
-            <p:nvSpPr>
-              <p:cNvPr id="26" name="TextBox 25">
-                <a:extLst>
-                  <a:ext uri="{FF2B5EF4-FFF2-40B4-BE49-F238E27FC236}">
-                    <a16:creationId xmlns:a16="http://schemas.microsoft.com/office/drawing/2014/main" id="{8C416952-CAB2-C7C5-6840-C2BB2171ECD0}"/>
-                  </a:ext>
-                </a:extLst>
-              </p:cNvPr>
-              <p:cNvSpPr txBox="1"/>
-              <p:nvPr/>
-            </p:nvSpPr>
-            <p:spPr>
-              <a:xfrm>
-                <a:off x="1853852" y="1478071"/>
-                <a:ext cx="317716" cy="369332"/>
-              </a:xfrm>
-              <a:prstGeom prst="rect">
-                <a:avLst/>
-              </a:prstGeom>
-              <a:noFill/>
-            </p:spPr>
-            <p:txBody>
-              <a:bodyPr wrap="none" rtlCol="0">
-                <a:spAutoFit/>
-              </a:bodyPr>
-              <a:lstStyle/>
-              <a:p>
-                <a:r>
-                  <a:rPr lang="en-US" dirty="0"/>
-                  <a:t>P</a:t>
-                </a:r>
-              </a:p>
-            </p:txBody>
-          </p:sp>
-          <p:sp>
-            <p:nvSpPr>
-              <p:cNvPr id="27" name="TextBox 26">
-                <a:extLst>
-                  <a:ext uri="{FF2B5EF4-FFF2-40B4-BE49-F238E27FC236}">
-                    <a16:creationId xmlns:a16="http://schemas.microsoft.com/office/drawing/2014/main" id="{32BCD7D9-A860-7D4B-61C6-5925834071A3}"/>
-                  </a:ext>
-                </a:extLst>
-              </p:cNvPr>
-              <p:cNvSpPr txBox="1"/>
-              <p:nvPr/>
-            </p:nvSpPr>
-            <p:spPr>
-              <a:xfrm>
-                <a:off x="7341609" y="5148197"/>
-                <a:ext cx="295274" cy="369332"/>
-              </a:xfrm>
-              <a:prstGeom prst="rect">
-                <a:avLst/>
-              </a:prstGeom>
-              <a:noFill/>
-            </p:spPr>
-            <p:txBody>
-              <a:bodyPr wrap="none" rtlCol="0">
-                <a:spAutoFit/>
-              </a:bodyPr>
-              <a:lstStyle/>
-              <a:p>
-                <a:r>
-                  <a:rPr lang="en-US" dirty="0"/>
-                  <a:t>T</a:t>
+                  <a:rPr lang="en-US" b="1" dirty="0"/>
+                  <a:t>water</a:t>
                 </a:r>
               </a:p>
             </p:txBody>
@@ -6204,10 +6260,10 @@
         </p:grpSp>
         <p:sp>
           <p:nvSpPr>
-            <p:cNvPr id="2" name="TextBox 1">
+            <p:cNvPr id="8" name="TextBox 7">
               <a:extLst>
                 <a:ext uri="{FF2B5EF4-FFF2-40B4-BE49-F238E27FC236}">
-                  <a16:creationId xmlns:a16="http://schemas.microsoft.com/office/drawing/2014/main" id="{198BCECC-52FA-5A31-417F-2498057E2510}"/>
+                  <a16:creationId xmlns:a16="http://schemas.microsoft.com/office/drawing/2014/main" id="{19086C91-5E34-F3D5-1F83-25DB16EE2112}"/>
                 </a:ext>
               </a:extLst>
             </p:cNvPr>
@@ -6216,8 +6272,8 @@
           </p:nvSpPr>
           <p:spPr>
             <a:xfrm>
-              <a:off x="5142557" y="989556"/>
-              <a:ext cx="777457" cy="369332"/>
+              <a:off x="4707534" y="1487373"/>
+              <a:ext cx="1614994" cy="646331"/>
             </a:xfrm>
             <a:prstGeom prst="rect">
               <a:avLst/>
@@ -6231,55 +6287,20 @@
             <a:lstStyle/>
             <a:p>
               <a:r>
-                <a:rPr lang="en-US" b="1" dirty="0"/>
-                <a:t>water</a:t>
+                <a:rPr lang="en-US" dirty="0"/>
+                <a:t>Slightly </a:t>
+              </a:r>
+              <a:br>
+                <a:rPr lang="en-US" dirty="0"/>
+              </a:br>
+              <a:r>
+                <a:rPr lang="en-US" dirty="0"/>
+                <a:t>negative slope</a:t>
               </a:r>
             </a:p>
           </p:txBody>
         </p:sp>
       </p:grpSp>
-      <p:sp>
-        <p:nvSpPr>
-          <p:cNvPr id="8" name="TextBox 7">
-            <a:extLst>
-              <a:ext uri="{FF2B5EF4-FFF2-40B4-BE49-F238E27FC236}">
-                <a16:creationId xmlns:a16="http://schemas.microsoft.com/office/drawing/2014/main" id="{19086C91-5E34-F3D5-1F83-25DB16EE2112}"/>
-              </a:ext>
-            </a:extLst>
-          </p:cNvPr>
-          <p:cNvSpPr txBox="1"/>
-          <p:nvPr/>
-        </p:nvSpPr>
-        <p:spPr>
-          <a:xfrm>
-            <a:off x="4707534" y="1487373"/>
-            <a:ext cx="1614994" cy="646331"/>
-          </a:xfrm>
-          <a:prstGeom prst="rect">
-            <a:avLst/>
-          </a:prstGeom>
-          <a:noFill/>
-        </p:spPr>
-        <p:txBody>
-          <a:bodyPr wrap="none" rtlCol="0">
-            <a:spAutoFit/>
-          </a:bodyPr>
-          <a:lstStyle/>
-          <a:p>
-            <a:r>
-              <a:rPr lang="en-US" dirty="0"/>
-              <a:t>Slightly </a:t>
-            </a:r>
-            <a:br>
-              <a:rPr lang="en-US" dirty="0"/>
-            </a:br>
-            <a:r>
-              <a:rPr lang="en-US" dirty="0"/>
-              <a:t>negative slope</a:t>
-            </a:r>
-          </a:p>
-        </p:txBody>
-      </p:sp>
     </p:spTree>
     <p:extLst>
       <p:ext uri="{BB962C8B-B14F-4D97-AF65-F5344CB8AC3E}">

</xml_diff>